<commit_message>
doc: update presentation info
</commit_message>
<xml_diff>
--- a/Documentation/mindmap_visual_presentation.pptx
+++ b/Documentation/mindmap_visual_presentation.pptx
@@ -7663,36 +7663,6 @@
           </a:p>
         </p:txBody>
       </p:sp>
-      <p:pic>
-        <p:nvPicPr>
-          <p:cNvPr id="4" name="Picture 3">
-            <a:extLst>
-              <a:ext uri="{FF2B5EF4-FFF2-40B4-BE49-F238E27FC236}">
-                <a16:creationId xmlns:a16="http://schemas.microsoft.com/office/drawing/2014/main" id="{7463FBBC-5530-A1C3-4971-12A97C38E876}"/>
-              </a:ext>
-            </a:extLst>
-          </p:cNvPr>
-          <p:cNvPicPr>
-            <a:picLocks noChangeAspect="1"/>
-          </p:cNvPicPr>
-          <p:nvPr/>
-        </p:nvPicPr>
-        <p:blipFill>
-          <a:blip r:embed="rId2"/>
-          <a:stretch>
-            <a:fillRect/>
-          </a:stretch>
-        </p:blipFill>
-        <p:spPr>
-          <a:xfrm>
-            <a:off x="5594073" y="2003062"/>
-            <a:ext cx="5996940" cy="3997960"/>
-          </a:xfrm>
-          <a:prstGeom prst="rect">
-            <a:avLst/>
-          </a:prstGeom>
-        </p:spPr>
-      </p:pic>
       <p:sp>
         <p:nvSpPr>
           <p:cNvPr id="5" name="Rounded Rectangle 3">
@@ -8116,6 +8086,36 @@
           </a:p>
         </p:txBody>
       </p:sp>
+      <p:pic>
+        <p:nvPicPr>
+          <p:cNvPr id="10" name="Picture 9">
+            <a:extLst>
+              <a:ext uri="{FF2B5EF4-FFF2-40B4-BE49-F238E27FC236}">
+                <a16:creationId xmlns:a16="http://schemas.microsoft.com/office/drawing/2014/main" id="{58ED5BE1-4279-904D-E679-DB200E16743B}"/>
+              </a:ext>
+            </a:extLst>
+          </p:cNvPr>
+          <p:cNvPicPr>
+            <a:picLocks noChangeAspect="1"/>
+          </p:cNvPicPr>
+          <p:nvPr/>
+        </p:nvPicPr>
+        <p:blipFill>
+          <a:blip r:embed="rId2"/>
+          <a:stretch>
+            <a:fillRect/>
+          </a:stretch>
+        </p:blipFill>
+        <p:spPr>
+          <a:xfrm>
+            <a:off x="5151582" y="1859280"/>
+            <a:ext cx="6333203" cy="4222135"/>
+          </a:xfrm>
+          <a:prstGeom prst="rect">
+            <a:avLst/>
+          </a:prstGeom>
+        </p:spPr>
+      </p:pic>
     </p:spTree>
     <p:extLst>
       <p:ext uri="{BB962C8B-B14F-4D97-AF65-F5344CB8AC3E}">
@@ -14062,10 +14062,40 @@
       </p:sp>
       <p:pic>
         <p:nvPicPr>
-          <p:cNvPr id="1026" name="Picture 2">
+          <p:cNvPr id="12" name="Picture 11">
             <a:extLst>
               <a:ext uri="{FF2B5EF4-FFF2-40B4-BE49-F238E27FC236}">
-                <a16:creationId xmlns:a16="http://schemas.microsoft.com/office/drawing/2014/main" id="{1A0390AF-D90D-A6E6-D599-24828C2B5AA3}"/>
+                <a16:creationId xmlns:a16="http://schemas.microsoft.com/office/drawing/2014/main" id="{D4E89FAE-BD0D-BA58-5C21-E512F5ABE050}"/>
+              </a:ext>
+            </a:extLst>
+          </p:cNvPr>
+          <p:cNvPicPr>
+            <a:picLocks noChangeAspect="1"/>
+          </p:cNvPicPr>
+          <p:nvPr/>
+        </p:nvPicPr>
+        <p:blipFill>
+          <a:blip r:embed="rId2"/>
+          <a:stretch>
+            <a:fillRect/>
+          </a:stretch>
+        </p:blipFill>
+        <p:spPr>
+          <a:xfrm>
+            <a:off x="7139890" y="1754935"/>
+            <a:ext cx="3300295" cy="2475221"/>
+          </a:xfrm>
+          <a:prstGeom prst="rect">
+            <a:avLst/>
+          </a:prstGeom>
+        </p:spPr>
+      </p:pic>
+      <p:pic>
+        <p:nvPicPr>
+          <p:cNvPr id="13" name="Picture 2">
+            <a:extLst>
+              <a:ext uri="{FF2B5EF4-FFF2-40B4-BE49-F238E27FC236}">
+                <a16:creationId xmlns:a16="http://schemas.microsoft.com/office/drawing/2014/main" id="{03C177BD-D47D-D010-26E1-4C0B54BBCD12}"/>
               </a:ext>
             </a:extLst>
           </p:cNvPr>
@@ -14075,7 +14105,7 @@
           <p:nvPr/>
         </p:nvPicPr>
         <p:blipFill>
-          <a:blip r:embed="rId2">
+          <a:blip r:embed="rId3">
             <a:extLst>
               <a:ext uri="{28A0092B-C50C-407E-A947-70E740481C1C}">
                 <a14:useLocalDpi xmlns:a14="http://schemas.microsoft.com/office/drawing/2010/main" val="0"/>
@@ -14089,55 +14119,8 @@
         </p:blipFill>
         <p:spPr bwMode="auto">
           <a:xfrm>
-            <a:off x="7295535" y="4198373"/>
-            <a:ext cx="3228116" cy="2421087"/>
-          </a:xfrm>
-          <a:prstGeom prst="rect">
-            <a:avLst/>
-          </a:prstGeom>
-          <a:noFill/>
-          <a:extLst>
-            <a:ext uri="{909E8E84-426E-40DD-AFC4-6F175D3DCCD1}">
-              <a14:hiddenFill xmlns:a14="http://schemas.microsoft.com/office/drawing/2010/main">
-                <a:solidFill>
-                  <a:srgbClr val="FFFFFF"/>
-                </a:solidFill>
-              </a14:hiddenFill>
-            </a:ext>
-          </a:extLst>
-        </p:spPr>
-      </p:pic>
-      <p:pic>
-        <p:nvPicPr>
-          <p:cNvPr id="1028" name="Picture 4">
-            <a:extLst>
-              <a:ext uri="{FF2B5EF4-FFF2-40B4-BE49-F238E27FC236}">
-                <a16:creationId xmlns:a16="http://schemas.microsoft.com/office/drawing/2014/main" id="{51D8B266-E104-3110-316A-CA9BD3CDC03E}"/>
-              </a:ext>
-            </a:extLst>
-          </p:cNvPr>
-          <p:cNvPicPr>
-            <a:picLocks noChangeAspect="1" noChangeArrowheads="1"/>
-          </p:cNvPicPr>
-          <p:nvPr/>
-        </p:nvPicPr>
-        <p:blipFill>
-          <a:blip r:embed="rId2">
-            <a:extLst>
-              <a:ext uri="{28A0092B-C50C-407E-A947-70E740481C1C}">
-                <a14:useLocalDpi xmlns:a14="http://schemas.microsoft.com/office/drawing/2010/main" val="0"/>
-              </a:ext>
-            </a:extLst>
-          </a:blip>
-          <a:srcRect/>
-          <a:stretch>
-            <a:fillRect/>
-          </a:stretch>
-        </p:blipFill>
-        <p:spPr bwMode="auto">
-          <a:xfrm>
-            <a:off x="7295533" y="1857828"/>
-            <a:ext cx="3228118" cy="2421088"/>
+            <a:off x="7139891" y="4093111"/>
+            <a:ext cx="3300295" cy="2475221"/>
           </a:xfrm>
           <a:prstGeom prst="rect">
             <a:avLst/>

</xml_diff>

<commit_message>
doc: update documents , changed mindmap or agenticflow to mind-flow
</commit_message>
<xml_diff>
--- a/Documentation/mindmap_visual_presentation.pptx
+++ b/Documentation/mindmap_visual_presentation.pptx
@@ -3291,7 +3291,7 @@
             </a:pPr>
             <a:r>
               <a:rPr lang="en-US" sz="3200" b="1" noProof="0" dirty="0"/>
-              <a:t>Mind Map</a:t>
+              <a:t>Mind Flow</a:t>
             </a:r>
           </a:p>
           <a:p>
@@ -4758,7 +4758,7 @@
             </a:pPr>
             <a:r>
               <a:rPr lang="en-US" noProof="0" dirty="0"/>
-              <a:t>Manual mind map evaluation is slow, subjective, and hard to scale.</a:t>
+              <a:t>Manual mind flow evaluation is slow, subjective, and hard to scale.</a:t>
             </a:r>
           </a:p>
         </p:txBody>

</xml_diff>